<commit_message>
Add README and QR code to AI in Peer Review materials
Add a README that describes each file in the folder, and add a QR code
that links to this folder on the last slide of the provocation deck.

Co-Authored-By: Claude Opus 5.5 <noreply@anthropic.com>
</commit_message>
<xml_diff>
--- a/AIME-Con 2026/AI in Peer Review/AI in Peer Review Provocation.pptx
+++ b/AIME-Con 2026/AI in Peer Review/AI in Peer Review Provocation.pptx
@@ -4325,6 +4325,77 @@
               <a:t>Precedent: COPE and NCME let a reviewer bring in a colleague if the journal knows who helped. Does that rule extend to AI?</a:t>
             </a:r>
             <a:endParaRPr lang="en-US" sz="1600" dirty="0"/>
+          </a:p>
+        </p:txBody>
+      </p:sp>
+      <p:pic>
+        <p:nvPicPr>
+          <p:cNvPr id="11" name="QR folder" descr="QR code linking to the AI in Peer Review folder on GitHub (slides and journal AI-policy scan)"/>
+          <p:cNvPicPr>
+            <a:picLocks noChangeAspect="1"/>
+          </p:cNvPicPr>
+          <p:nvPr/>
+        </p:nvPicPr>
+        <p:blipFill>
+          <a:blip r:embed="rId3"/>
+          <a:stretch>
+            <a:fillRect/>
+          </a:stretch>
+        </p:blipFill>
+        <p:spPr>
+          <a:xfrm>
+            <a:off x="10099017" y="4114800"/>
+            <a:ext cx="1280160" cy="1280160"/>
+          </a:xfrm>
+          <a:prstGeom prst="rect">
+            <a:avLst/>
+          </a:prstGeom>
+        </p:spPr>
+      </p:pic>
+      <p:sp>
+        <p:nvSpPr>
+          <p:cNvPr id="12" name="QR caption"/>
+          <p:cNvSpPr txBox="1"/>
+          <p:nvPr/>
+        </p:nvSpPr>
+        <p:spPr>
+          <a:xfrm>
+            <a:off x="6304257" y="4407408"/>
+            <a:ext cx="3566160" cy="731520"/>
+          </a:xfrm>
+          <a:prstGeom prst="rect">
+            <a:avLst/>
+          </a:prstGeom>
+          <a:noFill/>
+        </p:spPr>
+        <p:txBody>
+          <a:bodyPr wrap="square" anchor="ctr">
+            <a:spAutoFit/>
+          </a:bodyPr>
+          <a:lstStyle/>
+          <a:p>
+            <a:pPr algn="r"/>
+            <a:r>
+              <a:rPr sz="1200" b="1">
+                <a:solidFill>
+                  <a:srgbClr val="F2A65A"/>
+                </a:solidFill>
+                <a:latin typeface="IBM Plex Sans"/>
+              </a:rPr>
+              <a:t>SLIDES AND POLICY SCAN</a:t>
+            </a:r>
+          </a:p>
+          <a:p>
+            <a:pPr algn="r"/>
+            <a:r>
+              <a:rPr sz="1600" b="0">
+                <a:solidFill>
+                  <a:srgbClr val="C9D3E3"/>
+                </a:solidFill>
+                <a:latin typeface="IBM Plex Sans"/>
+              </a:rPr>
+              <a:t>Scan to open the folder on GitHub</a:t>
+            </a:r>
           </a:p>
         </p:txBody>
       </p:sp>

</xml_diff>